<commit_message>
Rulebook: replace text symbols with custom SVG icons
Slide 4 (Resources & Tracks):
  All 7 resource badge symbols replaced with PNG icons rendered from
  the game's SVG icon library: water_claim_track, water_claim,
  water_cube, money, pr, sc_influence, protest_influence.

Slide 5 (Cards & Markets):
  Card type header icons replaced: gain_lawyer (Lawyer), gain_activist
  (Activist), gain_farmer (Citizen), exhaust (Strategy),
  protest_influence (Event).

Slide 8 (Lawyers & Partnerships):
  Partnership card icons replaced: gain_lawyer (Law Firm),
  gain_activist (Business), income_track (Investment).

Slide 10 (Setup & Quick Reference):
  Section label accents use water_claim (Setup, Turn Actions)
  and money (Quick Numbers) icons.

Icons are 256×256 SVG-rendered PNGs embedded as base64 in the file.
All 14 icons match the visual language of the digital game's artwork
sessions: geometric shapes, game palette (teal/gold/terra/green),
dark background.
</commit_message>
<xml_diff>
--- a/law_of_the_river_rulebook.pptx
+++ b/law_of_the_river_rulebook.pptx
@@ -2676,16 +2676,40 @@
           </a:ln>
         </p:spPr>
       </p:sp>
-      <p:sp>
-        <p:nvSpPr>
-          <p:cNvPr id="8" name="Text 6"/>
-          <p:cNvSpPr/>
-          <p:nvPr/>
-        </p:nvSpPr>
+      <p:pic>
+        <p:nvPicPr>
+          <p:cNvPr id="8" name="Image 0" descr="preencoded.png">    </p:cNvPr>
+          <p:cNvPicPr>
+            <a:picLocks noChangeAspect="1"/>
+          </p:cNvPicPr>
+          <p:nvPr/>
+        </p:nvPicPr>
+        <p:blipFill>
+          <a:blip r:embed="rId1"/>
+          <a:stretch>
+            <a:fillRect/>
+          </a:stretch>
+        </p:blipFill>
         <p:spPr>
           <a:xfrm>
             <a:off x="457200" y="749808"/>
-            <a:ext cx="4206240" cy="256032"/>
+            <a:ext cx="256032" cy="256032"/>
+          </a:xfrm>
+          <a:prstGeom prst="rect">
+            <a:avLst/>
+          </a:prstGeom>
+        </p:spPr>
+      </p:pic>
+      <p:sp>
+        <p:nvSpPr>
+          <p:cNvPr id="9" name="Text 6"/>
+          <p:cNvSpPr/>
+          <p:nvPr/>
+        </p:nvSpPr>
+        <p:spPr>
+          <a:xfrm>
+            <a:off x="768096" y="749808"/>
+            <a:ext cx="3895344" cy="256032"/>
           </a:xfrm>
           <a:prstGeom prst="rect">
             <a:avLst/>
@@ -2717,7 +2741,7 @@
       </p:sp>
       <p:sp>
         <p:nvSpPr>
-          <p:cNvPr id="9" name="Text 7"/>
+          <p:cNvPr id="10" name="Text 7"/>
           <p:cNvSpPr/>
           <p:nvPr/>
         </p:nvSpPr>
@@ -2869,16 +2893,40 @@
           </a:p>
         </p:txBody>
       </p:sp>
-      <p:sp>
-        <p:nvSpPr>
-          <p:cNvPr id="10" name="Text 8"/>
-          <p:cNvSpPr/>
-          <p:nvPr/>
-        </p:nvSpPr>
+      <p:pic>
+        <p:nvPicPr>
+          <p:cNvPr id="11" name="Image 1" descr="preencoded.png">    </p:cNvPr>
+          <p:cNvPicPr>
+            <a:picLocks noChangeAspect="1"/>
+          </p:cNvPicPr>
+          <p:nvPr/>
+        </p:nvPicPr>
+        <p:blipFill>
+          <a:blip r:embed="rId2"/>
+          <a:stretch>
+            <a:fillRect/>
+          </a:stretch>
+        </p:blipFill>
         <p:spPr>
           <a:xfrm>
             <a:off x="457200" y="3054096"/>
-            <a:ext cx="4206240" cy="256032"/>
+            <a:ext cx="256032" cy="256032"/>
+          </a:xfrm>
+          <a:prstGeom prst="rect">
+            <a:avLst/>
+          </a:prstGeom>
+        </p:spPr>
+      </p:pic>
+      <p:sp>
+        <p:nvSpPr>
+          <p:cNvPr id="12" name="Text 8"/>
+          <p:cNvSpPr/>
+          <p:nvPr/>
+        </p:nvSpPr>
+        <p:spPr>
+          <a:xfrm>
+            <a:off x="768096" y="3054096"/>
+            <a:ext cx="3895344" cy="256032"/>
           </a:xfrm>
           <a:prstGeom prst="rect">
             <a:avLst/>
@@ -2910,7 +2958,7 @@
       </p:sp>
       <p:sp>
         <p:nvSpPr>
-          <p:cNvPr id="11" name="Shape 9"/>
+          <p:cNvPr id="13" name="Shape 9"/>
           <p:cNvSpPr/>
           <p:nvPr/>
         </p:nvSpPr>
@@ -2942,7 +2990,7 @@
       </p:sp>
       <p:sp>
         <p:nvSpPr>
-          <p:cNvPr id="12" name="Shape 10"/>
+          <p:cNvPr id="14" name="Shape 10"/>
           <p:cNvSpPr/>
           <p:nvPr/>
         </p:nvSpPr>
@@ -2967,7 +3015,7 @@
       </p:sp>
       <p:sp>
         <p:nvSpPr>
-          <p:cNvPr id="13" name="Shape 11"/>
+          <p:cNvPr id="15" name="Shape 11"/>
           <p:cNvSpPr/>
           <p:nvPr/>
         </p:nvSpPr>
@@ -2992,7 +3040,7 @@
       </p:sp>
       <p:sp>
         <p:nvSpPr>
-          <p:cNvPr id="14" name="Text 12"/>
+          <p:cNvPr id="16" name="Text 12"/>
           <p:cNvSpPr/>
           <p:nvPr/>
         </p:nvSpPr>
@@ -3031,7 +3079,7 @@
       </p:sp>
       <p:sp>
         <p:nvSpPr>
-          <p:cNvPr id="15" name="Text 13"/>
+          <p:cNvPr id="17" name="Text 13"/>
           <p:cNvSpPr/>
           <p:nvPr/>
         </p:nvSpPr>
@@ -3073,7 +3121,7 @@
       </p:sp>
       <p:sp>
         <p:nvSpPr>
-          <p:cNvPr id="16" name="Shape 14"/>
+          <p:cNvPr id="18" name="Shape 14"/>
           <p:cNvSpPr/>
           <p:nvPr/>
         </p:nvSpPr>
@@ -3105,7 +3153,7 @@
       </p:sp>
       <p:sp>
         <p:nvSpPr>
-          <p:cNvPr id="17" name="Shape 15"/>
+          <p:cNvPr id="19" name="Shape 15"/>
           <p:cNvSpPr/>
           <p:nvPr/>
         </p:nvSpPr>
@@ -3130,7 +3178,7 @@
       </p:sp>
       <p:sp>
         <p:nvSpPr>
-          <p:cNvPr id="18" name="Shape 16"/>
+          <p:cNvPr id="20" name="Shape 16"/>
           <p:cNvSpPr/>
           <p:nvPr/>
         </p:nvSpPr>
@@ -3155,7 +3203,7 @@
       </p:sp>
       <p:sp>
         <p:nvSpPr>
-          <p:cNvPr id="19" name="Text 17"/>
+          <p:cNvPr id="21" name="Text 17"/>
           <p:cNvSpPr/>
           <p:nvPr/>
         </p:nvSpPr>
@@ -3194,7 +3242,7 @@
       </p:sp>
       <p:sp>
         <p:nvSpPr>
-          <p:cNvPr id="20" name="Text 18"/>
+          <p:cNvPr id="22" name="Text 18"/>
           <p:cNvSpPr/>
           <p:nvPr/>
         </p:nvSpPr>
@@ -3234,16 +3282,40 @@
           </a:p>
         </p:txBody>
       </p:sp>
-      <p:sp>
-        <p:nvSpPr>
-          <p:cNvPr id="21" name="Text 19"/>
-          <p:cNvSpPr/>
-          <p:nvPr/>
-        </p:nvSpPr>
+      <p:pic>
+        <p:nvPicPr>
+          <p:cNvPr id="23" name="Image 2" descr="preencoded.png">    </p:cNvPr>
+          <p:cNvPicPr>
+            <a:picLocks noChangeAspect="1"/>
+          </p:cNvPicPr>
+          <p:nvPr/>
+        </p:nvPicPr>
+        <p:blipFill>
+          <a:blip r:embed="rId3"/>
+          <a:stretch>
+            <a:fillRect/>
+          </a:stretch>
+        </p:blipFill>
         <p:spPr>
           <a:xfrm>
             <a:off x="4846320" y="749808"/>
-            <a:ext cx="4023360" cy="256032"/>
+            <a:ext cx="256032" cy="256032"/>
+          </a:xfrm>
+          <a:prstGeom prst="rect">
+            <a:avLst/>
+          </a:prstGeom>
+        </p:spPr>
+      </p:pic>
+      <p:sp>
+        <p:nvSpPr>
+          <p:cNvPr id="24" name="Text 19"/>
+          <p:cNvSpPr/>
+          <p:nvPr/>
+        </p:nvSpPr>
+        <p:spPr>
+          <a:xfrm>
+            <a:off x="5157216" y="749808"/>
+            <a:ext cx="3712464" cy="256032"/>
           </a:xfrm>
           <a:prstGeom prst="rect">
             <a:avLst/>
@@ -3275,7 +3347,7 @@
       </p:sp>
       <p:sp>
         <p:nvSpPr>
-          <p:cNvPr id="22" name="Shape 20"/>
+          <p:cNvPr id="25" name="Shape 20"/>
           <p:cNvSpPr/>
           <p:nvPr/>
         </p:nvSpPr>
@@ -3300,7 +3372,7 @@
       </p:sp>
       <p:sp>
         <p:nvSpPr>
-          <p:cNvPr id="23" name="Text 21"/>
+          <p:cNvPr id="26" name="Text 21"/>
           <p:cNvSpPr/>
           <p:nvPr/>
         </p:nvSpPr>
@@ -3339,7 +3411,7 @@
       </p:sp>
       <p:sp>
         <p:nvSpPr>
-          <p:cNvPr id="24" name="Text 22"/>
+          <p:cNvPr id="27" name="Text 22"/>
           <p:cNvSpPr/>
           <p:nvPr/>
         </p:nvSpPr>
@@ -3378,7 +3450,7 @@
       </p:sp>
       <p:sp>
         <p:nvSpPr>
-          <p:cNvPr id="25" name="Shape 23"/>
+          <p:cNvPr id="28" name="Shape 23"/>
           <p:cNvSpPr/>
           <p:nvPr/>
         </p:nvSpPr>
@@ -3403,7 +3475,7 @@
       </p:sp>
       <p:sp>
         <p:nvSpPr>
-          <p:cNvPr id="26" name="Text 24"/>
+          <p:cNvPr id="29" name="Text 24"/>
           <p:cNvSpPr/>
           <p:nvPr/>
         </p:nvSpPr>
@@ -3442,7 +3514,7 @@
       </p:sp>
       <p:sp>
         <p:nvSpPr>
-          <p:cNvPr id="27" name="Text 25"/>
+          <p:cNvPr id="30" name="Text 25"/>
           <p:cNvSpPr/>
           <p:nvPr/>
         </p:nvSpPr>
@@ -3481,7 +3553,7 @@
       </p:sp>
       <p:sp>
         <p:nvSpPr>
-          <p:cNvPr id="28" name="Shape 26"/>
+          <p:cNvPr id="31" name="Shape 26"/>
           <p:cNvSpPr/>
           <p:nvPr/>
         </p:nvSpPr>
@@ -3506,7 +3578,7 @@
       </p:sp>
       <p:sp>
         <p:nvSpPr>
-          <p:cNvPr id="29" name="Text 27"/>
+          <p:cNvPr id="32" name="Text 27"/>
           <p:cNvSpPr/>
           <p:nvPr/>
         </p:nvSpPr>
@@ -3545,7 +3617,7 @@
       </p:sp>
       <p:sp>
         <p:nvSpPr>
-          <p:cNvPr id="30" name="Text 28"/>
+          <p:cNvPr id="33" name="Text 28"/>
           <p:cNvSpPr/>
           <p:nvPr/>
         </p:nvSpPr>
@@ -3584,7 +3656,7 @@
       </p:sp>
       <p:sp>
         <p:nvSpPr>
-          <p:cNvPr id="31" name="Shape 29"/>
+          <p:cNvPr id="34" name="Shape 29"/>
           <p:cNvSpPr/>
           <p:nvPr/>
         </p:nvSpPr>
@@ -3609,7 +3681,7 @@
       </p:sp>
       <p:sp>
         <p:nvSpPr>
-          <p:cNvPr id="32" name="Text 30"/>
+          <p:cNvPr id="35" name="Text 30"/>
           <p:cNvSpPr/>
           <p:nvPr/>
         </p:nvSpPr>
@@ -3648,7 +3720,7 @@
       </p:sp>
       <p:sp>
         <p:nvSpPr>
-          <p:cNvPr id="33" name="Text 31"/>
+          <p:cNvPr id="36" name="Text 31"/>
           <p:cNvSpPr/>
           <p:nvPr/>
         </p:nvSpPr>
@@ -3687,7 +3759,7 @@
       </p:sp>
       <p:sp>
         <p:nvSpPr>
-          <p:cNvPr id="34" name="Shape 32"/>
+          <p:cNvPr id="37" name="Shape 32"/>
           <p:cNvSpPr/>
           <p:nvPr/>
         </p:nvSpPr>
@@ -3712,7 +3784,7 @@
       </p:sp>
       <p:sp>
         <p:nvSpPr>
-          <p:cNvPr id="35" name="Text 33"/>
+          <p:cNvPr id="38" name="Text 33"/>
           <p:cNvSpPr/>
           <p:nvPr/>
         </p:nvSpPr>
@@ -3751,7 +3823,7 @@
       </p:sp>
       <p:sp>
         <p:nvSpPr>
-          <p:cNvPr id="36" name="Text 34"/>
+          <p:cNvPr id="39" name="Text 34"/>
           <p:cNvSpPr/>
           <p:nvPr/>
         </p:nvSpPr>
@@ -3790,7 +3862,7 @@
       </p:sp>
       <p:sp>
         <p:nvSpPr>
-          <p:cNvPr id="37" name="Shape 35"/>
+          <p:cNvPr id="40" name="Shape 35"/>
           <p:cNvSpPr/>
           <p:nvPr/>
         </p:nvSpPr>
@@ -3815,7 +3887,7 @@
       </p:sp>
       <p:sp>
         <p:nvSpPr>
-          <p:cNvPr id="38" name="Text 36"/>
+          <p:cNvPr id="41" name="Text 36"/>
           <p:cNvSpPr/>
           <p:nvPr/>
         </p:nvSpPr>
@@ -3854,7 +3926,7 @@
       </p:sp>
       <p:sp>
         <p:nvSpPr>
-          <p:cNvPr id="39" name="Text 37"/>
+          <p:cNvPr id="42" name="Text 37"/>
           <p:cNvSpPr/>
           <p:nvPr/>
         </p:nvSpPr>
@@ -3893,7 +3965,7 @@
       </p:sp>
       <p:sp>
         <p:nvSpPr>
-          <p:cNvPr id="40" name="Shape 38"/>
+          <p:cNvPr id="43" name="Shape 38"/>
           <p:cNvSpPr/>
           <p:nvPr/>
         </p:nvSpPr>
@@ -3918,7 +3990,7 @@
       </p:sp>
       <p:sp>
         <p:nvSpPr>
-          <p:cNvPr id="41" name="Text 39"/>
+          <p:cNvPr id="44" name="Text 39"/>
           <p:cNvSpPr/>
           <p:nvPr/>
         </p:nvSpPr>
@@ -3957,7 +4029,7 @@
       </p:sp>
       <p:sp>
         <p:nvSpPr>
-          <p:cNvPr id="42" name="Text 40"/>
+          <p:cNvPr id="45" name="Text 40"/>
           <p:cNvSpPr/>
           <p:nvPr/>
         </p:nvSpPr>
@@ -3996,7 +4068,7 @@
       </p:sp>
       <p:sp>
         <p:nvSpPr>
-          <p:cNvPr id="43" name="Shape 41"/>
+          <p:cNvPr id="46" name="Shape 41"/>
           <p:cNvSpPr/>
           <p:nvPr/>
         </p:nvSpPr>
@@ -4021,7 +4093,7 @@
       </p:sp>
       <p:sp>
         <p:nvSpPr>
-          <p:cNvPr id="44" name="Text 42"/>
+          <p:cNvPr id="47" name="Text 42"/>
           <p:cNvSpPr/>
           <p:nvPr/>
         </p:nvSpPr>
@@ -4060,7 +4132,7 @@
       </p:sp>
       <p:sp>
         <p:nvSpPr>
-          <p:cNvPr id="45" name="Text 43"/>
+          <p:cNvPr id="48" name="Text 43"/>
           <p:cNvSpPr/>
           <p:nvPr/>
         </p:nvSpPr>
@@ -4099,7 +4171,7 @@
       </p:sp>
       <p:sp>
         <p:nvSpPr>
-          <p:cNvPr id="46" name="Shape 44"/>
+          <p:cNvPr id="49" name="Shape 44"/>
           <p:cNvSpPr/>
           <p:nvPr/>
         </p:nvSpPr>
@@ -4131,7 +4203,7 @@
       </p:sp>
       <p:sp>
         <p:nvSpPr>
-          <p:cNvPr id="47" name="Text 45"/>
+          <p:cNvPr id="50" name="Text 45"/>
           <p:cNvSpPr/>
           <p:nvPr/>
         </p:nvSpPr>
@@ -4170,7 +4242,7 @@
       </p:sp>
       <p:sp>
         <p:nvSpPr>
-          <p:cNvPr id="48" name="Shape 46"/>
+          <p:cNvPr id="51" name="Shape 46"/>
           <p:cNvSpPr/>
           <p:nvPr/>
         </p:nvSpPr>
@@ -4193,7 +4265,7 @@
       </p:sp>
       <p:sp>
         <p:nvSpPr>
-          <p:cNvPr id="49" name="Text 47"/>
+          <p:cNvPr id="52" name="Text 47"/>
           <p:cNvSpPr/>
           <p:nvPr/>
         </p:nvSpPr>
@@ -7769,7 +7841,7 @@
         <p:spPr>
           <a:xfrm>
             <a:off x="347472" y="868680"/>
-            <a:ext cx="1042416" cy="713232"/>
+            <a:ext cx="1042416" cy="822960"/>
           </a:xfrm>
           <a:prstGeom prst="rect">
             <a:avLst/>
@@ -7792,16 +7864,40 @@
           </a:effectLst>
         </p:spPr>
       </p:sp>
-      <p:sp>
-        <p:nvSpPr>
-          <p:cNvPr id="8" name="Text 6"/>
-          <p:cNvSpPr/>
-          <p:nvPr/>
-        </p:nvSpPr>
-        <p:spPr>
-          <a:xfrm>
-            <a:off x="347472" y="886968"/>
-            <a:ext cx="1042416" cy="347472"/>
+      <p:pic>
+        <p:nvPicPr>
+          <p:cNvPr id="8" name="Image 0" descr="preencoded.png">    </p:cNvPr>
+          <p:cNvPicPr>
+            <a:picLocks noChangeAspect="1"/>
+          </p:cNvPicPr>
+          <p:nvPr/>
+        </p:nvPicPr>
+        <p:blipFill>
+          <a:blip r:embed="rId1"/>
+          <a:stretch>
+            <a:fillRect/>
+          </a:stretch>
+        </p:blipFill>
+        <p:spPr>
+          <a:xfrm>
+            <a:off x="548640" y="886968"/>
+            <a:ext cx="640080" cy="640080"/>
+          </a:xfrm>
+          <a:prstGeom prst="rect">
+            <a:avLst/>
+          </a:prstGeom>
+        </p:spPr>
+      </p:pic>
+      <p:sp>
+        <p:nvSpPr>
+          <p:cNvPr id="9" name="Text 6"/>
+          <p:cNvSpPr/>
+          <p:nvPr/>
+        </p:nvSpPr>
+        <p:spPr>
+          <a:xfrm>
+            <a:off x="347472" y="1426464"/>
+            <a:ext cx="1042416" cy="237744"/>
           </a:xfrm>
           <a:prstGeom prst="rect">
             <a:avLst/>
@@ -7817,43 +7913,7 @@
               <a:buNone/>
             </a:pPr>
             <a:r>
-              <a:rPr lang="en-US" sz="2400" dirty="0">
-                <a:solidFill>
-                  <a:srgbClr val="5DB8D4"/>
-                </a:solidFill>
-              </a:rPr>
-              <a:t>◈</a:t>
-            </a:r>
-            <a:endParaRPr lang="en-US" sz="2400" dirty="0"/>
-          </a:p>
-        </p:txBody>
-      </p:sp>
-      <p:sp>
-        <p:nvSpPr>
-          <p:cNvPr id="9" name="Text 7"/>
-          <p:cNvSpPr/>
-          <p:nvPr/>
-        </p:nvSpPr>
-        <p:spPr>
-          <a:xfrm>
-            <a:off x="347472" y="1207008"/>
-            <a:ext cx="1042416" cy="310896"/>
-          </a:xfrm>
-          <a:prstGeom prst="rect">
-            <a:avLst/>
-          </a:prstGeom>
-          <a:noFill/>
-          <a:ln/>
-        </p:spPr>
-        <p:txBody>
-          <a:bodyPr wrap="square" lIns="0" tIns="0" rIns="0" bIns="0" rtlCol="0" anchor="ctr"/>
-          <a:lstStyle/>
-          <a:p>
-            <a:pPr algn="ctr" indent="0" marL="0">
-              <a:buNone/>
-            </a:pPr>
-            <a:r>
-              <a:rPr lang="en-US" sz="700" spc="50" kern="0" dirty="0">
+              <a:rPr lang="en-US" sz="650" spc="50" kern="0" dirty="0">
                 <a:solidFill>
                   <a:srgbClr val="B09070"/>
                 </a:solidFill>
@@ -7863,14 +7923,14 @@
               </a:rPr>
               <a:t>WATER</a:t>
             </a:r>
-            <a:endParaRPr lang="en-US" sz="700" dirty="0"/>
+            <a:endParaRPr lang="en-US" sz="650" dirty="0"/>
           </a:p>
           <a:p>
             <a:pPr algn="ctr" indent="0" marL="0">
               <a:buNone/>
             </a:pPr>
             <a:r>
-              <a:rPr lang="en-US" sz="700" spc="50" kern="0" dirty="0">
+              <a:rPr lang="en-US" sz="650" spc="50" kern="0" dirty="0">
                 <a:solidFill>
                   <a:srgbClr val="B09070"/>
                 </a:solidFill>
@@ -7880,13 +7940,13 @@
               </a:rPr>
               <a:t>RIGHTS</a:t>
             </a:r>
-            <a:endParaRPr lang="en-US" sz="700" dirty="0"/>
-          </a:p>
-        </p:txBody>
-      </p:sp>
-      <p:sp>
-        <p:nvSpPr>
-          <p:cNvPr id="10" name="Text 8"/>
+            <a:endParaRPr lang="en-US" sz="650" dirty="0"/>
+          </a:p>
+        </p:txBody>
+      </p:sp>
+      <p:sp>
+        <p:nvSpPr>
+          <p:cNvPr id="10" name="Text 7"/>
           <p:cNvSpPr/>
           <p:nvPr/>
         </p:nvSpPr>
@@ -7920,7 +7980,7 @@
                 <a:ea typeface="EB Garamond" pitchFamily="34" charset="-122"/>
                 <a:cs typeface="EB Garamond" pitchFamily="34" charset="-120"/>
               </a:rPr>
-              <a:t>Track position. Income source. VP milestones at 6/11/17/22</a:t>
+              <a:t>Track position 3–22. Income source. VP milestones at 6/11/17/22.</a:t>
             </a:r>
             <a:endParaRPr lang="en-US" sz="900" dirty="0"/>
           </a:p>
@@ -7928,14 +7988,14 @@
       </p:sp>
       <p:sp>
         <p:nvSpPr>
-          <p:cNvPr id="11" name="Shape 9"/>
+          <p:cNvPr id="11" name="Shape 8"/>
           <p:cNvSpPr/>
           <p:nvPr/>
         </p:nvSpPr>
         <p:spPr>
           <a:xfrm>
             <a:off x="1572768" y="868680"/>
-            <a:ext cx="1042416" cy="713232"/>
+            <a:ext cx="1042416" cy="822960"/>
           </a:xfrm>
           <a:prstGeom prst="rect">
             <a:avLst/>
@@ -7958,16 +8018,40 @@
           </a:effectLst>
         </p:spPr>
       </p:sp>
-      <p:sp>
-        <p:nvSpPr>
-          <p:cNvPr id="12" name="Text 10"/>
-          <p:cNvSpPr/>
-          <p:nvPr/>
-        </p:nvSpPr>
-        <p:spPr>
-          <a:xfrm>
-            <a:off x="1572768" y="886968"/>
-            <a:ext cx="1042416" cy="347472"/>
+      <p:pic>
+        <p:nvPicPr>
+          <p:cNvPr id="12" name="Image 1" descr="preencoded.png">    </p:cNvPr>
+          <p:cNvPicPr>
+            <a:picLocks noChangeAspect="1"/>
+          </p:cNvPicPr>
+          <p:nvPr/>
+        </p:nvPicPr>
+        <p:blipFill>
+          <a:blip r:embed="rId2"/>
+          <a:stretch>
+            <a:fillRect/>
+          </a:stretch>
+        </p:blipFill>
+        <p:spPr>
+          <a:xfrm>
+            <a:off x="1773936" y="886968"/>
+            <a:ext cx="640080" cy="640080"/>
+          </a:xfrm>
+          <a:prstGeom prst="rect">
+            <a:avLst/>
+          </a:prstGeom>
+        </p:spPr>
+      </p:pic>
+      <p:sp>
+        <p:nvSpPr>
+          <p:cNvPr id="13" name="Text 9"/>
+          <p:cNvSpPr/>
+          <p:nvPr/>
+        </p:nvSpPr>
+        <p:spPr>
+          <a:xfrm>
+            <a:off x="1572768" y="1426464"/>
+            <a:ext cx="1042416" cy="237744"/>
           </a:xfrm>
           <a:prstGeom prst="rect">
             <a:avLst/>
@@ -7983,43 +8067,7 @@
               <a:buNone/>
             </a:pPr>
             <a:r>
-              <a:rPr lang="en-US" sz="2400" dirty="0">
-                <a:solidFill>
-                  <a:srgbClr val="3D8FA8"/>
-                </a:solidFill>
-              </a:rPr>
-              <a:t>◈</a:t>
-            </a:r>
-            <a:endParaRPr lang="en-US" sz="2400" dirty="0"/>
-          </a:p>
-        </p:txBody>
-      </p:sp>
-      <p:sp>
-        <p:nvSpPr>
-          <p:cNvPr id="13" name="Text 11"/>
-          <p:cNvSpPr/>
-          <p:nvPr/>
-        </p:nvSpPr>
-        <p:spPr>
-          <a:xfrm>
-            <a:off x="1572768" y="1207008"/>
-            <a:ext cx="1042416" cy="310896"/>
-          </a:xfrm>
-          <a:prstGeom prst="rect">
-            <a:avLst/>
-          </a:prstGeom>
-          <a:noFill/>
-          <a:ln/>
-        </p:spPr>
-        <p:txBody>
-          <a:bodyPr wrap="square" lIns="0" tIns="0" rIns="0" bIns="0" rtlCol="0" anchor="ctr"/>
-          <a:lstStyle/>
-          <a:p>
-            <a:pPr algn="ctr" indent="0" marL="0">
-              <a:buNone/>
-            </a:pPr>
-            <a:r>
-              <a:rPr lang="en-US" sz="700" spc="50" kern="0" dirty="0">
+              <a:rPr lang="en-US" sz="650" spc="50" kern="0" dirty="0">
                 <a:solidFill>
                   <a:srgbClr val="B09070"/>
                 </a:solidFill>
@@ -8029,14 +8077,14 @@
               </a:rPr>
               <a:t>WATER</a:t>
             </a:r>
-            <a:endParaRPr lang="en-US" sz="700" dirty="0"/>
+            <a:endParaRPr lang="en-US" sz="650" dirty="0"/>
           </a:p>
           <a:p>
             <a:pPr algn="ctr" indent="0" marL="0">
               <a:buNone/>
             </a:pPr>
             <a:r>
-              <a:rPr lang="en-US" sz="700" spc="50" kern="0" dirty="0">
+              <a:rPr lang="en-US" sz="650" spc="50" kern="0" dirty="0">
                 <a:solidFill>
                   <a:srgbClr val="B09070"/>
                 </a:solidFill>
@@ -8046,13 +8094,13 @@
               </a:rPr>
               <a:t>CLAIMS</a:t>
             </a:r>
-            <a:endParaRPr lang="en-US" sz="700" dirty="0"/>
-          </a:p>
-        </p:txBody>
-      </p:sp>
-      <p:sp>
-        <p:nvSpPr>
-          <p:cNvPr id="14" name="Text 12"/>
+            <a:endParaRPr lang="en-US" sz="650" dirty="0"/>
+          </a:p>
+        </p:txBody>
+      </p:sp>
+      <p:sp>
+        <p:nvSpPr>
+          <p:cNvPr id="14" name="Text 10"/>
           <p:cNvSpPr/>
           <p:nvPr/>
         </p:nvSpPr>
@@ -8094,14 +8142,14 @@
       </p:sp>
       <p:sp>
         <p:nvSpPr>
-          <p:cNvPr id="15" name="Shape 13"/>
+          <p:cNvPr id="15" name="Shape 11"/>
           <p:cNvSpPr/>
           <p:nvPr/>
         </p:nvSpPr>
         <p:spPr>
           <a:xfrm>
             <a:off x="2798064" y="868680"/>
-            <a:ext cx="1042416" cy="713232"/>
+            <a:ext cx="1042416" cy="822960"/>
           </a:xfrm>
           <a:prstGeom prst="rect">
             <a:avLst/>
@@ -8124,16 +8172,40 @@
           </a:effectLst>
         </p:spPr>
       </p:sp>
-      <p:sp>
-        <p:nvSpPr>
-          <p:cNvPr id="16" name="Text 14"/>
-          <p:cNvSpPr/>
-          <p:nvPr/>
-        </p:nvSpPr>
-        <p:spPr>
-          <a:xfrm>
-            <a:off x="2798064" y="886968"/>
-            <a:ext cx="1042416" cy="347472"/>
+      <p:pic>
+        <p:nvPicPr>
+          <p:cNvPr id="16" name="Image 2" descr="preencoded.png">    </p:cNvPr>
+          <p:cNvPicPr>
+            <a:picLocks noChangeAspect="1"/>
+          </p:cNvPicPr>
+          <p:nvPr/>
+        </p:nvPicPr>
+        <p:blipFill>
+          <a:blip r:embed="rId3"/>
+          <a:stretch>
+            <a:fillRect/>
+          </a:stretch>
+        </p:blipFill>
+        <p:spPr>
+          <a:xfrm>
+            <a:off x="2999232" y="886968"/>
+            <a:ext cx="640080" cy="640080"/>
+          </a:xfrm>
+          <a:prstGeom prst="rect">
+            <a:avLst/>
+          </a:prstGeom>
+        </p:spPr>
+      </p:pic>
+      <p:sp>
+        <p:nvSpPr>
+          <p:cNvPr id="17" name="Text 12"/>
+          <p:cNvSpPr/>
+          <p:nvPr/>
+        </p:nvSpPr>
+        <p:spPr>
+          <a:xfrm>
+            <a:off x="2798064" y="1426464"/>
+            <a:ext cx="1042416" cy="237744"/>
           </a:xfrm>
           <a:prstGeom prst="rect">
             <a:avLst/>
@@ -8149,43 +8221,7 @@
               <a:buNone/>
             </a:pPr>
             <a:r>
-              <a:rPr lang="en-US" sz="2400" dirty="0">
-                <a:solidFill>
-                  <a:srgbClr val="3D8FA8"/>
-                </a:solidFill>
-              </a:rPr>
-              <a:t>💧</a:t>
-            </a:r>
-            <a:endParaRPr lang="en-US" sz="2400" dirty="0"/>
-          </a:p>
-        </p:txBody>
-      </p:sp>
-      <p:sp>
-        <p:nvSpPr>
-          <p:cNvPr id="17" name="Text 15"/>
-          <p:cNvSpPr/>
-          <p:nvPr/>
-        </p:nvSpPr>
-        <p:spPr>
-          <a:xfrm>
-            <a:off x="2798064" y="1207008"/>
-            <a:ext cx="1042416" cy="310896"/>
-          </a:xfrm>
-          <a:prstGeom prst="rect">
-            <a:avLst/>
-          </a:prstGeom>
-          <a:noFill/>
-          <a:ln/>
-        </p:spPr>
-        <p:txBody>
-          <a:bodyPr wrap="square" lIns="0" tIns="0" rIns="0" bIns="0" rtlCol="0" anchor="ctr"/>
-          <a:lstStyle/>
-          <a:p>
-            <a:pPr algn="ctr" indent="0" marL="0">
-              <a:buNone/>
-            </a:pPr>
-            <a:r>
-              <a:rPr lang="en-US" sz="700" spc="50" kern="0" dirty="0">
+              <a:rPr lang="en-US" sz="650" spc="50" kern="0" dirty="0">
                 <a:solidFill>
                   <a:srgbClr val="B09070"/>
                 </a:solidFill>
@@ -8195,14 +8231,14 @@
               </a:rPr>
               <a:t>WATER</a:t>
             </a:r>
-            <a:endParaRPr lang="en-US" sz="700" dirty="0"/>
+            <a:endParaRPr lang="en-US" sz="650" dirty="0"/>
           </a:p>
           <a:p>
             <a:pPr algn="ctr" indent="0" marL="0">
               <a:buNone/>
             </a:pPr>
             <a:r>
-              <a:rPr lang="en-US" sz="700" spc="50" kern="0" dirty="0">
+              <a:rPr lang="en-US" sz="650" spc="50" kern="0" dirty="0">
                 <a:solidFill>
                   <a:srgbClr val="B09070"/>
                 </a:solidFill>
@@ -8212,13 +8248,13 @@
               </a:rPr>
               <a:t>CUBES</a:t>
             </a:r>
-            <a:endParaRPr lang="en-US" sz="700" dirty="0"/>
-          </a:p>
-        </p:txBody>
-      </p:sp>
-      <p:sp>
-        <p:nvSpPr>
-          <p:cNvPr id="18" name="Text 16"/>
+            <a:endParaRPr lang="en-US" sz="650" dirty="0"/>
+          </a:p>
+        </p:txBody>
+      </p:sp>
+      <p:sp>
+        <p:nvSpPr>
+          <p:cNvPr id="18" name="Text 13"/>
           <p:cNvSpPr/>
           <p:nvPr/>
         </p:nvSpPr>
@@ -8260,14 +8296,14 @@
       </p:sp>
       <p:sp>
         <p:nvSpPr>
-          <p:cNvPr id="19" name="Shape 17"/>
+          <p:cNvPr id="19" name="Shape 14"/>
           <p:cNvSpPr/>
           <p:nvPr/>
         </p:nvSpPr>
         <p:spPr>
           <a:xfrm>
             <a:off x="4023360" y="868680"/>
-            <a:ext cx="1042416" cy="713232"/>
+            <a:ext cx="1042416" cy="822960"/>
           </a:xfrm>
           <a:prstGeom prst="rect">
             <a:avLst/>
@@ -8290,16 +8326,40 @@
           </a:effectLst>
         </p:spPr>
       </p:sp>
-      <p:sp>
-        <p:nvSpPr>
-          <p:cNvPr id="20" name="Text 18"/>
-          <p:cNvSpPr/>
-          <p:nvPr/>
-        </p:nvSpPr>
-        <p:spPr>
-          <a:xfrm>
-            <a:off x="4023360" y="886968"/>
-            <a:ext cx="1042416" cy="347472"/>
+      <p:pic>
+        <p:nvPicPr>
+          <p:cNvPr id="20" name="Image 3" descr="preencoded.png">    </p:cNvPr>
+          <p:cNvPicPr>
+            <a:picLocks noChangeAspect="1"/>
+          </p:cNvPicPr>
+          <p:nvPr/>
+        </p:nvPicPr>
+        <p:blipFill>
+          <a:blip r:embed="rId4"/>
+          <a:stretch>
+            <a:fillRect/>
+          </a:stretch>
+        </p:blipFill>
+        <p:spPr>
+          <a:xfrm>
+            <a:off x="4224528" y="886968"/>
+            <a:ext cx="640080" cy="640080"/>
+          </a:xfrm>
+          <a:prstGeom prst="rect">
+            <a:avLst/>
+          </a:prstGeom>
+        </p:spPr>
+      </p:pic>
+      <p:sp>
+        <p:nvSpPr>
+          <p:cNvPr id="21" name="Text 15"/>
+          <p:cNvSpPr/>
+          <p:nvPr/>
+        </p:nvSpPr>
+        <p:spPr>
+          <a:xfrm>
+            <a:off x="4023360" y="1426464"/>
+            <a:ext cx="1042416" cy="237744"/>
           </a:xfrm>
           <a:prstGeom prst="rect">
             <a:avLst/>
@@ -8315,43 +8375,7 @@
               <a:buNone/>
             </a:pPr>
             <a:r>
-              <a:rPr lang="en-US" sz="2400" dirty="0">
-                <a:solidFill>
-                  <a:srgbClr val="C8A550"/>
-                </a:solidFill>
-              </a:rPr>
-              <a:t>$</a:t>
-            </a:r>
-            <a:endParaRPr lang="en-US" sz="2400" dirty="0"/>
-          </a:p>
-        </p:txBody>
-      </p:sp>
-      <p:sp>
-        <p:nvSpPr>
-          <p:cNvPr id="21" name="Text 19"/>
-          <p:cNvSpPr/>
-          <p:nvPr/>
-        </p:nvSpPr>
-        <p:spPr>
-          <a:xfrm>
-            <a:off x="4023360" y="1207008"/>
-            <a:ext cx="1042416" cy="310896"/>
-          </a:xfrm>
-          <a:prstGeom prst="rect">
-            <a:avLst/>
-          </a:prstGeom>
-          <a:noFill/>
-          <a:ln/>
-        </p:spPr>
-        <p:txBody>
-          <a:bodyPr wrap="square" lIns="0" tIns="0" rIns="0" bIns="0" rtlCol="0" anchor="ctr"/>
-          <a:lstStyle/>
-          <a:p>
-            <a:pPr algn="ctr" indent="0" marL="0">
-              <a:buNone/>
-            </a:pPr>
-            <a:r>
-              <a:rPr lang="en-US" sz="700" spc="50" kern="0" dirty="0">
+              <a:rPr lang="en-US" sz="650" spc="50" kern="0" dirty="0">
                 <a:solidFill>
                   <a:srgbClr val="B09070"/>
                 </a:solidFill>
@@ -8361,13 +8385,13 @@
               </a:rPr>
               <a:t>MONEY</a:t>
             </a:r>
-            <a:endParaRPr lang="en-US" sz="700" dirty="0"/>
-          </a:p>
-        </p:txBody>
-      </p:sp>
-      <p:sp>
-        <p:nvSpPr>
-          <p:cNvPr id="22" name="Text 20"/>
+            <a:endParaRPr lang="en-US" sz="650" dirty="0"/>
+          </a:p>
+        </p:txBody>
+      </p:sp>
+      <p:sp>
+        <p:nvSpPr>
+          <p:cNvPr id="22" name="Text 16"/>
           <p:cNvSpPr/>
           <p:nvPr/>
         </p:nvSpPr>
@@ -8409,14 +8433,14 @@
       </p:sp>
       <p:sp>
         <p:nvSpPr>
-          <p:cNvPr id="23" name="Shape 21"/>
+          <p:cNvPr id="23" name="Shape 17"/>
           <p:cNvSpPr/>
           <p:nvPr/>
         </p:nvSpPr>
         <p:spPr>
           <a:xfrm>
             <a:off x="5248656" y="868680"/>
-            <a:ext cx="1042416" cy="713232"/>
+            <a:ext cx="1042416" cy="822960"/>
           </a:xfrm>
           <a:prstGeom prst="rect">
             <a:avLst/>
@@ -8439,16 +8463,40 @@
           </a:effectLst>
         </p:spPr>
       </p:sp>
-      <p:sp>
-        <p:nvSpPr>
-          <p:cNvPr id="24" name="Text 22"/>
-          <p:cNvSpPr/>
-          <p:nvPr/>
-        </p:nvSpPr>
-        <p:spPr>
-          <a:xfrm>
-            <a:off x="5248656" y="886968"/>
-            <a:ext cx="1042416" cy="347472"/>
+      <p:pic>
+        <p:nvPicPr>
+          <p:cNvPr id="24" name="Image 4" descr="preencoded.png">    </p:cNvPr>
+          <p:cNvPicPr>
+            <a:picLocks noChangeAspect="1"/>
+          </p:cNvPicPr>
+          <p:nvPr/>
+        </p:nvPicPr>
+        <p:blipFill>
+          <a:blip r:embed="rId5"/>
+          <a:stretch>
+            <a:fillRect/>
+          </a:stretch>
+        </p:blipFill>
+        <p:spPr>
+          <a:xfrm>
+            <a:off x="5449824" y="886968"/>
+            <a:ext cx="640080" cy="640080"/>
+          </a:xfrm>
+          <a:prstGeom prst="rect">
+            <a:avLst/>
+          </a:prstGeom>
+        </p:spPr>
+      </p:pic>
+      <p:sp>
+        <p:nvSpPr>
+          <p:cNvPr id="25" name="Text 18"/>
+          <p:cNvSpPr/>
+          <p:nvPr/>
+        </p:nvSpPr>
+        <p:spPr>
+          <a:xfrm>
+            <a:off x="5248656" y="1426464"/>
+            <a:ext cx="1042416" cy="237744"/>
           </a:xfrm>
           <a:prstGeom prst="rect">
             <a:avLst/>
@@ -8464,43 +8512,7 @@
               <a:buNone/>
             </a:pPr>
             <a:r>
-              <a:rPr lang="en-US" sz="2400" dirty="0">
-                <a:solidFill>
-                  <a:srgbClr val="7EB87E"/>
-                </a:solidFill>
-              </a:rPr>
-              <a:t>★</a:t>
-            </a:r>
-            <a:endParaRPr lang="en-US" sz="2400" dirty="0"/>
-          </a:p>
-        </p:txBody>
-      </p:sp>
-      <p:sp>
-        <p:nvSpPr>
-          <p:cNvPr id="25" name="Text 23"/>
-          <p:cNvSpPr/>
-          <p:nvPr/>
-        </p:nvSpPr>
-        <p:spPr>
-          <a:xfrm>
-            <a:off x="5248656" y="1207008"/>
-            <a:ext cx="1042416" cy="310896"/>
-          </a:xfrm>
-          <a:prstGeom prst="rect">
-            <a:avLst/>
-          </a:prstGeom>
-          <a:noFill/>
-          <a:ln/>
-        </p:spPr>
-        <p:txBody>
-          <a:bodyPr wrap="square" lIns="0" tIns="0" rIns="0" bIns="0" rtlCol="0" anchor="ctr"/>
-          <a:lstStyle/>
-          <a:p>
-            <a:pPr algn="ctr" indent="0" marL="0">
-              <a:buNone/>
-            </a:pPr>
-            <a:r>
-              <a:rPr lang="en-US" sz="700" spc="50" kern="0" dirty="0">
+              <a:rPr lang="en-US" sz="650" spc="50" kern="0" dirty="0">
                 <a:solidFill>
                   <a:srgbClr val="B09070"/>
                 </a:solidFill>
@@ -8510,13 +8522,13 @@
               </a:rPr>
               <a:t>PR</a:t>
             </a:r>
-            <a:endParaRPr lang="en-US" sz="700" dirty="0"/>
-          </a:p>
-        </p:txBody>
-      </p:sp>
-      <p:sp>
-        <p:nvSpPr>
-          <p:cNvPr id="26" name="Text 24"/>
+            <a:endParaRPr lang="en-US" sz="650" dirty="0"/>
+          </a:p>
+        </p:txBody>
+      </p:sp>
+      <p:sp>
+        <p:nvSpPr>
+          <p:cNvPr id="26" name="Text 19"/>
           <p:cNvSpPr/>
           <p:nvPr/>
         </p:nvSpPr>
@@ -8558,14 +8570,14 @@
       </p:sp>
       <p:sp>
         <p:nvSpPr>
-          <p:cNvPr id="27" name="Shape 25"/>
+          <p:cNvPr id="27" name="Shape 20"/>
           <p:cNvSpPr/>
           <p:nvPr/>
         </p:nvSpPr>
         <p:spPr>
           <a:xfrm>
             <a:off x="6473952" y="868680"/>
-            <a:ext cx="1042416" cy="713232"/>
+            <a:ext cx="1042416" cy="822960"/>
           </a:xfrm>
           <a:prstGeom prst="rect">
             <a:avLst/>
@@ -8588,16 +8600,40 @@
           </a:effectLst>
         </p:spPr>
       </p:sp>
-      <p:sp>
-        <p:nvSpPr>
-          <p:cNvPr id="28" name="Text 26"/>
-          <p:cNvSpPr/>
-          <p:nvPr/>
-        </p:nvSpPr>
-        <p:spPr>
-          <a:xfrm>
-            <a:off x="6473952" y="886968"/>
-            <a:ext cx="1042416" cy="347472"/>
+      <p:pic>
+        <p:nvPicPr>
+          <p:cNvPr id="28" name="Image 5" descr="preencoded.png">    </p:cNvPr>
+          <p:cNvPicPr>
+            <a:picLocks noChangeAspect="1"/>
+          </p:cNvPicPr>
+          <p:nvPr/>
+        </p:nvPicPr>
+        <p:blipFill>
+          <a:blip r:embed="rId6"/>
+          <a:stretch>
+            <a:fillRect/>
+          </a:stretch>
+        </p:blipFill>
+        <p:spPr>
+          <a:xfrm>
+            <a:off x="6675120" y="886968"/>
+            <a:ext cx="640080" cy="640080"/>
+          </a:xfrm>
+          <a:prstGeom prst="rect">
+            <a:avLst/>
+          </a:prstGeom>
+        </p:spPr>
+      </p:pic>
+      <p:sp>
+        <p:nvSpPr>
+          <p:cNvPr id="29" name="Text 21"/>
+          <p:cNvSpPr/>
+          <p:nvPr/>
+        </p:nvSpPr>
+        <p:spPr>
+          <a:xfrm>
+            <a:off x="6473952" y="1426464"/>
+            <a:ext cx="1042416" cy="237744"/>
           </a:xfrm>
           <a:prstGeom prst="rect">
             <a:avLst/>
@@ -8613,43 +8649,7 @@
               <a:buNone/>
             </a:pPr>
             <a:r>
-              <a:rPr lang="en-US" sz="2400" dirty="0">
-                <a:solidFill>
-                  <a:srgbClr val="C8A550"/>
-                </a:solidFill>
-              </a:rPr>
-              <a:t>⚖</a:t>
-            </a:r>
-            <a:endParaRPr lang="en-US" sz="2400" dirty="0"/>
-          </a:p>
-        </p:txBody>
-      </p:sp>
-      <p:sp>
-        <p:nvSpPr>
-          <p:cNvPr id="29" name="Text 27"/>
-          <p:cNvSpPr/>
-          <p:nvPr/>
-        </p:nvSpPr>
-        <p:spPr>
-          <a:xfrm>
-            <a:off x="6473952" y="1207008"/>
-            <a:ext cx="1042416" cy="310896"/>
-          </a:xfrm>
-          <a:prstGeom prst="rect">
-            <a:avLst/>
-          </a:prstGeom>
-          <a:noFill/>
-          <a:ln/>
-        </p:spPr>
-        <p:txBody>
-          <a:bodyPr wrap="square" lIns="0" tIns="0" rIns="0" bIns="0" rtlCol="0" anchor="ctr"/>
-          <a:lstStyle/>
-          <a:p>
-            <a:pPr algn="ctr" indent="0" marL="0">
-              <a:buNone/>
-            </a:pPr>
-            <a:r>
-              <a:rPr lang="en-US" sz="700" spc="50" kern="0" dirty="0">
+              <a:rPr lang="en-US" sz="650" spc="50" kern="0" dirty="0">
                 <a:solidFill>
                   <a:srgbClr val="B09070"/>
                 </a:solidFill>
@@ -8659,14 +8659,14 @@
               </a:rPr>
               <a:t>SC</a:t>
             </a:r>
-            <a:endParaRPr lang="en-US" sz="700" dirty="0"/>
+            <a:endParaRPr lang="en-US" sz="650" dirty="0"/>
           </a:p>
           <a:p>
             <a:pPr algn="ctr" indent="0" marL="0">
               <a:buNone/>
             </a:pPr>
             <a:r>
-              <a:rPr lang="en-US" sz="700" spc="50" kern="0" dirty="0">
+              <a:rPr lang="en-US" sz="650" spc="50" kern="0" dirty="0">
                 <a:solidFill>
                   <a:srgbClr val="B09070"/>
                 </a:solidFill>
@@ -8676,13 +8676,13 @@
               </a:rPr>
               <a:t>INFLUENCE</a:t>
             </a:r>
-            <a:endParaRPr lang="en-US" sz="700" dirty="0"/>
-          </a:p>
-        </p:txBody>
-      </p:sp>
-      <p:sp>
-        <p:nvSpPr>
-          <p:cNvPr id="30" name="Text 28"/>
+            <a:endParaRPr lang="en-US" sz="650" dirty="0"/>
+          </a:p>
+        </p:txBody>
+      </p:sp>
+      <p:sp>
+        <p:nvSpPr>
+          <p:cNvPr id="30" name="Text 22"/>
           <p:cNvSpPr/>
           <p:nvPr/>
         </p:nvSpPr>
@@ -8724,14 +8724,14 @@
       </p:sp>
       <p:sp>
         <p:nvSpPr>
-          <p:cNvPr id="31" name="Shape 29"/>
+          <p:cNvPr id="31" name="Shape 23"/>
           <p:cNvSpPr/>
           <p:nvPr/>
         </p:nvSpPr>
         <p:spPr>
           <a:xfrm>
             <a:off x="7699248" y="868680"/>
-            <a:ext cx="1042416" cy="713232"/>
+            <a:ext cx="1042416" cy="822960"/>
           </a:xfrm>
           <a:prstGeom prst="rect">
             <a:avLst/>
@@ -8754,16 +8754,40 @@
           </a:effectLst>
         </p:spPr>
       </p:sp>
-      <p:sp>
-        <p:nvSpPr>
-          <p:cNvPr id="32" name="Text 30"/>
-          <p:cNvSpPr/>
-          <p:nvPr/>
-        </p:nvSpPr>
-        <p:spPr>
-          <a:xfrm>
-            <a:off x="7699248" y="886968"/>
-            <a:ext cx="1042416" cy="347472"/>
+      <p:pic>
+        <p:nvPicPr>
+          <p:cNvPr id="32" name="Image 6" descr="preencoded.png">    </p:cNvPr>
+          <p:cNvPicPr>
+            <a:picLocks noChangeAspect="1"/>
+          </p:cNvPicPr>
+          <p:nvPr/>
+        </p:nvPicPr>
+        <p:blipFill>
+          <a:blip r:embed="rId7"/>
+          <a:stretch>
+            <a:fillRect/>
+          </a:stretch>
+        </p:blipFill>
+        <p:spPr>
+          <a:xfrm>
+            <a:off x="7900416" y="886968"/>
+            <a:ext cx="640080" cy="640080"/>
+          </a:xfrm>
+          <a:prstGeom prst="rect">
+            <a:avLst/>
+          </a:prstGeom>
+        </p:spPr>
+      </p:pic>
+      <p:sp>
+        <p:nvSpPr>
+          <p:cNvPr id="33" name="Text 24"/>
+          <p:cNvSpPr/>
+          <p:nvPr/>
+        </p:nvSpPr>
+        <p:spPr>
+          <a:xfrm>
+            <a:off x="7699248" y="1426464"/>
+            <a:ext cx="1042416" cy="237744"/>
           </a:xfrm>
           <a:prstGeom prst="rect">
             <a:avLst/>
@@ -8779,43 +8803,7 @@
               <a:buNone/>
             </a:pPr>
             <a:r>
-              <a:rPr lang="en-US" sz="2400" dirty="0">
-                <a:solidFill>
-                  <a:srgbClr val="7EB87E"/>
-                </a:solidFill>
-              </a:rPr>
-              <a:t>✊</a:t>
-            </a:r>
-            <a:endParaRPr lang="en-US" sz="2400" dirty="0"/>
-          </a:p>
-        </p:txBody>
-      </p:sp>
-      <p:sp>
-        <p:nvSpPr>
-          <p:cNvPr id="33" name="Text 31"/>
-          <p:cNvSpPr/>
-          <p:nvPr/>
-        </p:nvSpPr>
-        <p:spPr>
-          <a:xfrm>
-            <a:off x="7699248" y="1207008"/>
-            <a:ext cx="1042416" cy="310896"/>
-          </a:xfrm>
-          <a:prstGeom prst="rect">
-            <a:avLst/>
-          </a:prstGeom>
-          <a:noFill/>
-          <a:ln/>
-        </p:spPr>
-        <p:txBody>
-          <a:bodyPr wrap="square" lIns="0" tIns="0" rIns="0" bIns="0" rtlCol="0" anchor="ctr"/>
-          <a:lstStyle/>
-          <a:p>
-            <a:pPr algn="ctr" indent="0" marL="0">
-              <a:buNone/>
-            </a:pPr>
-            <a:r>
-              <a:rPr lang="en-US" sz="700" spc="50" kern="0" dirty="0">
+              <a:rPr lang="en-US" sz="650" spc="50" kern="0" dirty="0">
                 <a:solidFill>
                   <a:srgbClr val="B09070"/>
                 </a:solidFill>
@@ -8825,14 +8813,14 @@
               </a:rPr>
               <a:t>PROTEST</a:t>
             </a:r>
-            <a:endParaRPr lang="en-US" sz="700" dirty="0"/>
+            <a:endParaRPr lang="en-US" sz="650" dirty="0"/>
           </a:p>
           <a:p>
             <a:pPr algn="ctr" indent="0" marL="0">
               <a:buNone/>
             </a:pPr>
             <a:r>
-              <a:rPr lang="en-US" sz="700" spc="50" kern="0" dirty="0">
+              <a:rPr lang="en-US" sz="650" spc="50" kern="0" dirty="0">
                 <a:solidFill>
                   <a:srgbClr val="B09070"/>
                 </a:solidFill>
@@ -8842,13 +8830,13 @@
               </a:rPr>
               <a:t>INFL.</a:t>
             </a:r>
-            <a:endParaRPr lang="en-US" sz="700" dirty="0"/>
-          </a:p>
-        </p:txBody>
-      </p:sp>
-      <p:sp>
-        <p:nvSpPr>
-          <p:cNvPr id="34" name="Text 32"/>
+            <a:endParaRPr lang="en-US" sz="650" dirty="0"/>
+          </a:p>
+        </p:txBody>
+      </p:sp>
+      <p:sp>
+        <p:nvSpPr>
+          <p:cNvPr id="34" name="Text 25"/>
           <p:cNvSpPr/>
           <p:nvPr/>
         </p:nvSpPr>
@@ -8890,7 +8878,7 @@
       </p:sp>
       <p:sp>
         <p:nvSpPr>
-          <p:cNvPr id="35" name="Shape 33"/>
+          <p:cNvPr id="35" name="Shape 26"/>
           <p:cNvSpPr/>
           <p:nvPr/>
         </p:nvSpPr>
@@ -8913,7 +8901,7 @@
       </p:sp>
       <p:sp>
         <p:nvSpPr>
-          <p:cNvPr id="36" name="Shape 34"/>
+          <p:cNvPr id="36" name="Shape 27"/>
           <p:cNvSpPr/>
           <p:nvPr/>
         </p:nvSpPr>
@@ -8945,7 +8933,7 @@
       </p:sp>
       <p:sp>
         <p:nvSpPr>
-          <p:cNvPr id="37" name="Shape 35"/>
+          <p:cNvPr id="37" name="Shape 28"/>
           <p:cNvSpPr/>
           <p:nvPr/>
         </p:nvSpPr>
@@ -8970,7 +8958,7 @@
       </p:sp>
       <p:sp>
         <p:nvSpPr>
-          <p:cNvPr id="38" name="Shape 36"/>
+          <p:cNvPr id="38" name="Shape 29"/>
           <p:cNvSpPr/>
           <p:nvPr/>
         </p:nvSpPr>
@@ -8990,7 +8978,7 @@
       </p:sp>
       <p:sp>
         <p:nvSpPr>
-          <p:cNvPr id="39" name="Text 37"/>
+          <p:cNvPr id="39" name="Text 30"/>
           <p:cNvSpPr/>
           <p:nvPr/>
         </p:nvSpPr>
@@ -9029,7 +9017,7 @@
       </p:sp>
       <p:sp>
         <p:nvSpPr>
-          <p:cNvPr id="40" name="Text 38"/>
+          <p:cNvPr id="40" name="Text 31"/>
           <p:cNvSpPr/>
           <p:nvPr/>
         </p:nvSpPr>
@@ -9068,7 +9056,7 @@
       </p:sp>
       <p:sp>
         <p:nvSpPr>
-          <p:cNvPr id="41" name="Text 39"/>
+          <p:cNvPr id="41" name="Text 32"/>
           <p:cNvSpPr/>
           <p:nvPr/>
         </p:nvSpPr>
@@ -9107,7 +9095,7 @@
       </p:sp>
       <p:sp>
         <p:nvSpPr>
-          <p:cNvPr id="42" name="Shape 40"/>
+          <p:cNvPr id="42" name="Shape 33"/>
           <p:cNvSpPr/>
           <p:nvPr/>
         </p:nvSpPr>
@@ -9130,7 +9118,7 @@
       </p:sp>
       <p:sp>
         <p:nvSpPr>
-          <p:cNvPr id="43" name="Text 41"/>
+          <p:cNvPr id="43" name="Text 34"/>
           <p:cNvSpPr/>
           <p:nvPr/>
         </p:nvSpPr>
@@ -9172,7 +9160,7 @@
       </p:sp>
       <p:sp>
         <p:nvSpPr>
-          <p:cNvPr id="44" name="Shape 42"/>
+          <p:cNvPr id="44" name="Shape 35"/>
           <p:cNvSpPr/>
           <p:nvPr/>
         </p:nvSpPr>
@@ -9204,7 +9192,7 @@
       </p:sp>
       <p:sp>
         <p:nvSpPr>
-          <p:cNvPr id="45" name="Shape 43"/>
+          <p:cNvPr id="45" name="Shape 36"/>
           <p:cNvSpPr/>
           <p:nvPr/>
         </p:nvSpPr>
@@ -9229,7 +9217,7 @@
       </p:sp>
       <p:sp>
         <p:nvSpPr>
-          <p:cNvPr id="46" name="Shape 44"/>
+          <p:cNvPr id="46" name="Shape 37"/>
           <p:cNvSpPr/>
           <p:nvPr/>
         </p:nvSpPr>
@@ -9249,7 +9237,7 @@
       </p:sp>
       <p:sp>
         <p:nvSpPr>
-          <p:cNvPr id="47" name="Text 45"/>
+          <p:cNvPr id="47" name="Text 38"/>
           <p:cNvSpPr/>
           <p:nvPr/>
         </p:nvSpPr>
@@ -9288,7 +9276,7 @@
       </p:sp>
       <p:sp>
         <p:nvSpPr>
-          <p:cNvPr id="48" name="Text 46"/>
+          <p:cNvPr id="48" name="Text 39"/>
           <p:cNvSpPr/>
           <p:nvPr/>
         </p:nvSpPr>
@@ -9327,7 +9315,7 @@
       </p:sp>
       <p:sp>
         <p:nvSpPr>
-          <p:cNvPr id="49" name="Text 47"/>
+          <p:cNvPr id="49" name="Text 40"/>
           <p:cNvSpPr/>
           <p:nvPr/>
         </p:nvSpPr>
@@ -9366,7 +9354,7 @@
       </p:sp>
       <p:sp>
         <p:nvSpPr>
-          <p:cNvPr id="50" name="Shape 48"/>
+          <p:cNvPr id="50" name="Shape 41"/>
           <p:cNvSpPr/>
           <p:nvPr/>
         </p:nvSpPr>
@@ -9389,7 +9377,7 @@
       </p:sp>
       <p:sp>
         <p:nvSpPr>
-          <p:cNvPr id="51" name="Text 49"/>
+          <p:cNvPr id="51" name="Text 42"/>
           <p:cNvSpPr/>
           <p:nvPr/>
         </p:nvSpPr>
@@ -9431,7 +9419,7 @@
       </p:sp>
       <p:sp>
         <p:nvSpPr>
-          <p:cNvPr id="52" name="Shape 50"/>
+          <p:cNvPr id="52" name="Shape 43"/>
           <p:cNvSpPr/>
           <p:nvPr/>
         </p:nvSpPr>
@@ -9463,7 +9451,7 @@
       </p:sp>
       <p:sp>
         <p:nvSpPr>
-          <p:cNvPr id="53" name="Shape 51"/>
+          <p:cNvPr id="53" name="Shape 44"/>
           <p:cNvSpPr/>
           <p:nvPr/>
         </p:nvSpPr>
@@ -9488,7 +9476,7 @@
       </p:sp>
       <p:sp>
         <p:nvSpPr>
-          <p:cNvPr id="54" name="Shape 52"/>
+          <p:cNvPr id="54" name="Shape 45"/>
           <p:cNvSpPr/>
           <p:nvPr/>
         </p:nvSpPr>
@@ -9508,7 +9496,7 @@
       </p:sp>
       <p:sp>
         <p:nvSpPr>
-          <p:cNvPr id="55" name="Text 53"/>
+          <p:cNvPr id="55" name="Text 46"/>
           <p:cNvSpPr/>
           <p:nvPr/>
         </p:nvSpPr>
@@ -9547,7 +9535,7 @@
       </p:sp>
       <p:sp>
         <p:nvSpPr>
-          <p:cNvPr id="56" name="Text 54"/>
+          <p:cNvPr id="56" name="Text 47"/>
           <p:cNvSpPr/>
           <p:nvPr/>
         </p:nvSpPr>
@@ -9586,7 +9574,7 @@
       </p:sp>
       <p:sp>
         <p:nvSpPr>
-          <p:cNvPr id="57" name="Text 55"/>
+          <p:cNvPr id="57" name="Text 48"/>
           <p:cNvSpPr/>
           <p:nvPr/>
         </p:nvSpPr>
@@ -9625,7 +9613,7 @@
       </p:sp>
       <p:sp>
         <p:nvSpPr>
-          <p:cNvPr id="58" name="Shape 56"/>
+          <p:cNvPr id="58" name="Shape 49"/>
           <p:cNvSpPr/>
           <p:nvPr/>
         </p:nvSpPr>
@@ -9648,7 +9636,7 @@
       </p:sp>
       <p:sp>
         <p:nvSpPr>
-          <p:cNvPr id="59" name="Text 57"/>
+          <p:cNvPr id="59" name="Text 50"/>
           <p:cNvSpPr/>
           <p:nvPr/>
         </p:nvSpPr>
@@ -9910,16 +9898,40 @@
           </a:ln>
         </p:spPr>
       </p:sp>
-      <p:sp>
-        <p:nvSpPr>
-          <p:cNvPr id="9" name="Text 7"/>
-          <p:cNvSpPr/>
-          <p:nvPr/>
-        </p:nvSpPr>
-        <p:spPr>
-          <a:xfrm>
-            <a:off x="475488" y="914400"/>
-            <a:ext cx="3840480" cy="256032"/>
+      <p:pic>
+        <p:nvPicPr>
+          <p:cNvPr id="9" name="Image 0" descr="preencoded.png">    </p:cNvPr>
+          <p:cNvPicPr>
+            <a:picLocks noChangeAspect="1"/>
+          </p:cNvPicPr>
+          <p:nvPr/>
+        </p:nvPicPr>
+        <p:blipFill>
+          <a:blip r:embed="rId1"/>
+          <a:stretch>
+            <a:fillRect/>
+          </a:stretch>
+        </p:blipFill>
+        <p:spPr>
+          <a:xfrm>
+            <a:off x="438912" y="886968"/>
+            <a:ext cx="274320" cy="274320"/>
+          </a:xfrm>
+          <a:prstGeom prst="rect">
+            <a:avLst/>
+          </a:prstGeom>
+        </p:spPr>
+      </p:pic>
+      <p:sp>
+        <p:nvSpPr>
+          <p:cNvPr id="10" name="Text 7"/>
+          <p:cNvSpPr/>
+          <p:nvPr/>
+        </p:nvSpPr>
+        <p:spPr>
+          <a:xfrm>
+            <a:off x="768096" y="914400"/>
+            <a:ext cx="3657600" cy="256032"/>
           </a:xfrm>
           <a:prstGeom prst="rect">
             <a:avLst/>
@@ -9943,7 +9955,7 @@
                 <a:ea typeface="Courier New" pitchFamily="34" charset="-122"/>
                 <a:cs typeface="Courier New" pitchFamily="34" charset="-120"/>
               </a:rPr>
-              <a:t>⚖  LAWYER</a:t>
+              <a:t>LAWYER</a:t>
             </a:r>
             <a:endParaRPr lang="en-US" sz="950" dirty="0"/>
           </a:p>
@@ -9951,7 +9963,7 @@
       </p:sp>
       <p:sp>
         <p:nvSpPr>
-          <p:cNvPr id="10" name="Text 8"/>
+          <p:cNvPr id="11" name="Text 8"/>
           <p:cNvSpPr/>
           <p:nvPr/>
         </p:nvSpPr>
@@ -10057,7 +10069,7 @@
       </p:sp>
       <p:sp>
         <p:nvSpPr>
-          <p:cNvPr id="11" name="Shape 9"/>
+          <p:cNvPr id="12" name="Shape 9"/>
           <p:cNvSpPr/>
           <p:nvPr/>
         </p:nvSpPr>
@@ -10089,7 +10101,7 @@
       </p:sp>
       <p:sp>
         <p:nvSpPr>
-          <p:cNvPr id="12" name="Shape 10"/>
+          <p:cNvPr id="13" name="Shape 10"/>
           <p:cNvSpPr/>
           <p:nvPr/>
         </p:nvSpPr>
@@ -10114,16 +10126,40 @@
           </a:ln>
         </p:spPr>
       </p:sp>
-      <p:sp>
-        <p:nvSpPr>
-          <p:cNvPr id="13" name="Text 11"/>
-          <p:cNvSpPr/>
-          <p:nvPr/>
-        </p:nvSpPr>
-        <p:spPr>
-          <a:xfrm>
-            <a:off x="475488" y="2267712"/>
-            <a:ext cx="3840480" cy="256032"/>
+      <p:pic>
+        <p:nvPicPr>
+          <p:cNvPr id="14" name="Image 1" descr="preencoded.png">    </p:cNvPr>
+          <p:cNvPicPr>
+            <a:picLocks noChangeAspect="1"/>
+          </p:cNvPicPr>
+          <p:nvPr/>
+        </p:nvPicPr>
+        <p:blipFill>
+          <a:blip r:embed="rId2"/>
+          <a:stretch>
+            <a:fillRect/>
+          </a:stretch>
+        </p:blipFill>
+        <p:spPr>
+          <a:xfrm>
+            <a:off x="438912" y="2240280"/>
+            <a:ext cx="274320" cy="274320"/>
+          </a:xfrm>
+          <a:prstGeom prst="rect">
+            <a:avLst/>
+          </a:prstGeom>
+        </p:spPr>
+      </p:pic>
+      <p:sp>
+        <p:nvSpPr>
+          <p:cNvPr id="15" name="Text 11"/>
+          <p:cNvSpPr/>
+          <p:nvPr/>
+        </p:nvSpPr>
+        <p:spPr>
+          <a:xfrm>
+            <a:off x="768096" y="2267712"/>
+            <a:ext cx="3657600" cy="256032"/>
           </a:xfrm>
           <a:prstGeom prst="rect">
             <a:avLst/>
@@ -10147,7 +10183,7 @@
                 <a:ea typeface="Courier New" pitchFamily="34" charset="-122"/>
                 <a:cs typeface="Courier New" pitchFamily="34" charset="-120"/>
               </a:rPr>
-              <a:t>✊  ACTIVIST</a:t>
+              <a:t>ACTIVIST</a:t>
             </a:r>
             <a:endParaRPr lang="en-US" sz="950" dirty="0"/>
           </a:p>
@@ -10155,7 +10191,7 @@
       </p:sp>
       <p:sp>
         <p:nvSpPr>
-          <p:cNvPr id="14" name="Text 12"/>
+          <p:cNvPr id="16" name="Text 12"/>
           <p:cNvSpPr/>
           <p:nvPr/>
         </p:nvSpPr>
@@ -10261,7 +10297,7 @@
       </p:sp>
       <p:sp>
         <p:nvSpPr>
-          <p:cNvPr id="15" name="Shape 13"/>
+          <p:cNvPr id="17" name="Shape 13"/>
           <p:cNvSpPr/>
           <p:nvPr/>
         </p:nvSpPr>
@@ -10293,7 +10329,7 @@
       </p:sp>
       <p:sp>
         <p:nvSpPr>
-          <p:cNvPr id="16" name="Shape 14"/>
+          <p:cNvPr id="18" name="Shape 14"/>
           <p:cNvSpPr/>
           <p:nvPr/>
         </p:nvSpPr>
@@ -10318,16 +10354,40 @@
           </a:ln>
         </p:spPr>
       </p:sp>
-      <p:sp>
-        <p:nvSpPr>
-          <p:cNvPr id="17" name="Text 15"/>
-          <p:cNvSpPr/>
-          <p:nvPr/>
-        </p:nvSpPr>
-        <p:spPr>
-          <a:xfrm>
-            <a:off x="475488" y="3621024"/>
-            <a:ext cx="3840480" cy="256032"/>
+      <p:pic>
+        <p:nvPicPr>
+          <p:cNvPr id="19" name="Image 2" descr="preencoded.png">    </p:cNvPr>
+          <p:cNvPicPr>
+            <a:picLocks noChangeAspect="1"/>
+          </p:cNvPicPr>
+          <p:nvPr/>
+        </p:nvPicPr>
+        <p:blipFill>
+          <a:blip r:embed="rId3"/>
+          <a:stretch>
+            <a:fillRect/>
+          </a:stretch>
+        </p:blipFill>
+        <p:spPr>
+          <a:xfrm>
+            <a:off x="438912" y="3593592"/>
+            <a:ext cx="274320" cy="274320"/>
+          </a:xfrm>
+          <a:prstGeom prst="rect">
+            <a:avLst/>
+          </a:prstGeom>
+        </p:spPr>
+      </p:pic>
+      <p:sp>
+        <p:nvSpPr>
+          <p:cNvPr id="20" name="Text 15"/>
+          <p:cNvSpPr/>
+          <p:nvPr/>
+        </p:nvSpPr>
+        <p:spPr>
+          <a:xfrm>
+            <a:off x="768096" y="3621024"/>
+            <a:ext cx="3657600" cy="256032"/>
           </a:xfrm>
           <a:prstGeom prst="rect">
             <a:avLst/>
@@ -10351,7 +10411,7 @@
                 <a:ea typeface="Courier New" pitchFamily="34" charset="-122"/>
                 <a:cs typeface="Courier New" pitchFamily="34" charset="-120"/>
               </a:rPr>
-              <a:t>🧑  CITIZEN</a:t>
+              <a:t>CITIZEN</a:t>
             </a:r>
             <a:endParaRPr lang="en-US" sz="950" dirty="0"/>
           </a:p>
@@ -10359,7 +10419,7 @@
       </p:sp>
       <p:sp>
         <p:nvSpPr>
-          <p:cNvPr id="18" name="Text 16"/>
+          <p:cNvPr id="21" name="Text 16"/>
           <p:cNvSpPr/>
           <p:nvPr/>
         </p:nvSpPr>
@@ -10444,7 +10504,7 @@
       </p:sp>
       <p:sp>
         <p:nvSpPr>
-          <p:cNvPr id="19" name="Shape 17"/>
+          <p:cNvPr id="22" name="Shape 17"/>
           <p:cNvSpPr/>
           <p:nvPr/>
         </p:nvSpPr>
@@ -10476,7 +10536,7 @@
       </p:sp>
       <p:sp>
         <p:nvSpPr>
-          <p:cNvPr id="20" name="Shape 18"/>
+          <p:cNvPr id="23" name="Shape 18"/>
           <p:cNvSpPr/>
           <p:nvPr/>
         </p:nvSpPr>
@@ -10501,16 +10561,40 @@
           </a:ln>
         </p:spPr>
       </p:sp>
-      <p:sp>
-        <p:nvSpPr>
-          <p:cNvPr id="21" name="Text 19"/>
-          <p:cNvSpPr/>
-          <p:nvPr/>
-        </p:nvSpPr>
-        <p:spPr>
-          <a:xfrm>
-            <a:off x="4910328" y="914400"/>
-            <a:ext cx="3840480" cy="256032"/>
+      <p:pic>
+        <p:nvPicPr>
+          <p:cNvPr id="24" name="Image 3" descr="preencoded.png">    </p:cNvPr>
+          <p:cNvPicPr>
+            <a:picLocks noChangeAspect="1"/>
+          </p:cNvPicPr>
+          <p:nvPr/>
+        </p:nvPicPr>
+        <p:blipFill>
+          <a:blip r:embed="rId4"/>
+          <a:stretch>
+            <a:fillRect/>
+          </a:stretch>
+        </p:blipFill>
+        <p:spPr>
+          <a:xfrm>
+            <a:off x="4873752" y="886968"/>
+            <a:ext cx="274320" cy="274320"/>
+          </a:xfrm>
+          <a:prstGeom prst="rect">
+            <a:avLst/>
+          </a:prstGeom>
+        </p:spPr>
+      </p:pic>
+      <p:sp>
+        <p:nvSpPr>
+          <p:cNvPr id="25" name="Text 19"/>
+          <p:cNvSpPr/>
+          <p:nvPr/>
+        </p:nvSpPr>
+        <p:spPr>
+          <a:xfrm>
+            <a:off x="5202936" y="914400"/>
+            <a:ext cx="3657600" cy="256032"/>
           </a:xfrm>
           <a:prstGeom prst="rect">
             <a:avLst/>
@@ -10534,7 +10618,7 @@
                 <a:ea typeface="Courier New" pitchFamily="34" charset="-122"/>
                 <a:cs typeface="Courier New" pitchFamily="34" charset="-120"/>
               </a:rPr>
-              <a:t>📋  STRATEGY</a:t>
+              <a:t>STRATEGY</a:t>
             </a:r>
             <a:endParaRPr lang="en-US" sz="950" dirty="0"/>
           </a:p>
@@ -10542,7 +10626,7 @@
       </p:sp>
       <p:sp>
         <p:nvSpPr>
-          <p:cNvPr id="22" name="Text 20"/>
+          <p:cNvPr id="26" name="Text 20"/>
           <p:cNvSpPr/>
           <p:nvPr/>
         </p:nvSpPr>
@@ -10648,7 +10732,7 @@
       </p:sp>
       <p:sp>
         <p:nvSpPr>
-          <p:cNvPr id="23" name="Shape 21"/>
+          <p:cNvPr id="27" name="Shape 21"/>
           <p:cNvSpPr/>
           <p:nvPr/>
         </p:nvSpPr>
@@ -10680,7 +10764,7 @@
       </p:sp>
       <p:sp>
         <p:nvSpPr>
-          <p:cNvPr id="24" name="Shape 22"/>
+          <p:cNvPr id="28" name="Shape 22"/>
           <p:cNvSpPr/>
           <p:nvPr/>
         </p:nvSpPr>
@@ -10705,16 +10789,40 @@
           </a:ln>
         </p:spPr>
       </p:sp>
-      <p:sp>
-        <p:nvSpPr>
-          <p:cNvPr id="25" name="Text 23"/>
-          <p:cNvSpPr/>
-          <p:nvPr/>
-        </p:nvSpPr>
-        <p:spPr>
-          <a:xfrm>
-            <a:off x="4910328" y="2267712"/>
-            <a:ext cx="3840480" cy="256032"/>
+      <p:pic>
+        <p:nvPicPr>
+          <p:cNvPr id="29" name="Image 4" descr="preencoded.png">    </p:cNvPr>
+          <p:cNvPicPr>
+            <a:picLocks noChangeAspect="1"/>
+          </p:cNvPicPr>
+          <p:nvPr/>
+        </p:nvPicPr>
+        <p:blipFill>
+          <a:blip r:embed="rId5"/>
+          <a:stretch>
+            <a:fillRect/>
+          </a:stretch>
+        </p:blipFill>
+        <p:spPr>
+          <a:xfrm>
+            <a:off x="4873752" y="2240280"/>
+            <a:ext cx="274320" cy="274320"/>
+          </a:xfrm>
+          <a:prstGeom prst="rect">
+            <a:avLst/>
+          </a:prstGeom>
+        </p:spPr>
+      </p:pic>
+      <p:sp>
+        <p:nvSpPr>
+          <p:cNvPr id="30" name="Text 23"/>
+          <p:cNvSpPr/>
+          <p:nvPr/>
+        </p:nvSpPr>
+        <p:spPr>
+          <a:xfrm>
+            <a:off x="5202936" y="2267712"/>
+            <a:ext cx="3657600" cy="256032"/>
           </a:xfrm>
           <a:prstGeom prst="rect">
             <a:avLst/>
@@ -10738,7 +10846,7 @@
                 <a:ea typeface="Courier New" pitchFamily="34" charset="-122"/>
                 <a:cs typeface="Courier New" pitchFamily="34" charset="-120"/>
               </a:rPr>
-              <a:t>⚡  EVENT</a:t>
+              <a:t>EVENT</a:t>
             </a:r>
             <a:endParaRPr lang="en-US" sz="950" dirty="0"/>
           </a:p>
@@ -10746,7 +10854,7 @@
       </p:sp>
       <p:sp>
         <p:nvSpPr>
-          <p:cNvPr id="26" name="Text 24"/>
+          <p:cNvPr id="31" name="Text 24"/>
           <p:cNvSpPr/>
           <p:nvPr/>
         </p:nvSpPr>
@@ -17510,16 +17618,40 @@
           </a:effectLst>
         </p:spPr>
       </p:sp>
-      <p:sp>
-        <p:nvSpPr>
-          <p:cNvPr id="66" name="Text 64"/>
-          <p:cNvSpPr/>
-          <p:nvPr/>
-        </p:nvSpPr>
-        <p:spPr>
-          <a:xfrm>
-            <a:off x="6108192" y="1188720"/>
-            <a:ext cx="2560320" cy="274320"/>
+      <p:pic>
+        <p:nvPicPr>
+          <p:cNvPr id="66" name="Image 0" descr="preencoded.png">    </p:cNvPr>
+          <p:cNvPicPr>
+            <a:picLocks noChangeAspect="1"/>
+          </p:cNvPicPr>
+          <p:nvPr/>
+        </p:nvPicPr>
+        <p:blipFill>
+          <a:blip r:embed="rId1"/>
+          <a:stretch>
+            <a:fillRect/>
+          </a:stretch>
+        </p:blipFill>
+        <p:spPr>
+          <a:xfrm>
+            <a:off x="6035040" y="1188720"/>
+            <a:ext cx="274320" cy="274320"/>
+          </a:xfrm>
+          <a:prstGeom prst="rect">
+            <a:avLst/>
+          </a:prstGeom>
+        </p:spPr>
+      </p:pic>
+      <p:sp>
+        <p:nvSpPr>
+          <p:cNvPr id="67" name="Text 64"/>
+          <p:cNvSpPr/>
+          <p:nvPr/>
+        </p:nvSpPr>
+        <p:spPr>
+          <a:xfrm>
+            <a:off x="6364224" y="1188720"/>
+            <a:ext cx="2304288" cy="274320"/>
           </a:xfrm>
           <a:prstGeom prst="rect">
             <a:avLst/>
@@ -17543,7 +17675,7 @@
                 <a:ea typeface="Courier New" pitchFamily="34" charset="-122"/>
                 <a:cs typeface="Courier New" pitchFamily="34" charset="-120"/>
               </a:rPr>
-              <a:t>⚖  LAW FIRM</a:t>
+              <a:t>LAW FIRM</a:t>
             </a:r>
             <a:endParaRPr lang="en-US" sz="950" dirty="0"/>
           </a:p>
@@ -17551,7 +17683,7 @@
       </p:sp>
       <p:sp>
         <p:nvSpPr>
-          <p:cNvPr id="67" name="Text 65"/>
+          <p:cNvPr id="68" name="Text 65"/>
           <p:cNvSpPr/>
           <p:nvPr/>
         </p:nvSpPr>
@@ -17590,7 +17722,7 @@
       </p:sp>
       <p:sp>
         <p:nvSpPr>
-          <p:cNvPr id="68" name="Shape 66"/>
+          <p:cNvPr id="69" name="Shape 66"/>
           <p:cNvSpPr/>
           <p:nvPr/>
         </p:nvSpPr>
@@ -17613,7 +17745,7 @@
       </p:sp>
       <p:sp>
         <p:nvSpPr>
-          <p:cNvPr id="69" name="Text 67"/>
+          <p:cNvPr id="70" name="Text 67"/>
           <p:cNvSpPr/>
           <p:nvPr/>
         </p:nvSpPr>
@@ -17655,7 +17787,7 @@
       </p:sp>
       <p:sp>
         <p:nvSpPr>
-          <p:cNvPr id="70" name="Shape 68"/>
+          <p:cNvPr id="71" name="Shape 68"/>
           <p:cNvSpPr/>
           <p:nvPr/>
         </p:nvSpPr>
@@ -17685,16 +17817,40 @@
           </a:effectLst>
         </p:spPr>
       </p:sp>
-      <p:sp>
-        <p:nvSpPr>
-          <p:cNvPr id="71" name="Text 69"/>
-          <p:cNvSpPr/>
-          <p:nvPr/>
-        </p:nvSpPr>
-        <p:spPr>
-          <a:xfrm>
-            <a:off x="6108192" y="2340864"/>
-            <a:ext cx="2560320" cy="274320"/>
+      <p:pic>
+        <p:nvPicPr>
+          <p:cNvPr id="72" name="Image 1" descr="preencoded.png">    </p:cNvPr>
+          <p:cNvPicPr>
+            <a:picLocks noChangeAspect="1"/>
+          </p:cNvPicPr>
+          <p:nvPr/>
+        </p:nvPicPr>
+        <p:blipFill>
+          <a:blip r:embed="rId2"/>
+          <a:stretch>
+            <a:fillRect/>
+          </a:stretch>
+        </p:blipFill>
+        <p:spPr>
+          <a:xfrm>
+            <a:off x="6035040" y="2340864"/>
+            <a:ext cx="274320" cy="274320"/>
+          </a:xfrm>
+          <a:prstGeom prst="rect">
+            <a:avLst/>
+          </a:prstGeom>
+        </p:spPr>
+      </p:pic>
+      <p:sp>
+        <p:nvSpPr>
+          <p:cNvPr id="73" name="Text 69"/>
+          <p:cNvSpPr/>
+          <p:nvPr/>
+        </p:nvSpPr>
+        <p:spPr>
+          <a:xfrm>
+            <a:off x="6364224" y="2340864"/>
+            <a:ext cx="2304288" cy="274320"/>
           </a:xfrm>
           <a:prstGeom prst="rect">
             <a:avLst/>
@@ -17718,7 +17874,7 @@
                 <a:ea typeface="Courier New" pitchFamily="34" charset="-122"/>
                 <a:cs typeface="Courier New" pitchFamily="34" charset="-120"/>
               </a:rPr>
-              <a:t>🤝  BUSINESS</a:t>
+              <a:t>BUSINESS</a:t>
             </a:r>
             <a:endParaRPr lang="en-US" sz="950" dirty="0"/>
           </a:p>
@@ -17726,7 +17882,7 @@
       </p:sp>
       <p:sp>
         <p:nvSpPr>
-          <p:cNvPr id="72" name="Text 70"/>
+          <p:cNvPr id="74" name="Text 70"/>
           <p:cNvSpPr/>
           <p:nvPr/>
         </p:nvSpPr>
@@ -17765,7 +17921,7 @@
       </p:sp>
       <p:sp>
         <p:nvSpPr>
-          <p:cNvPr id="73" name="Shape 71"/>
+          <p:cNvPr id="75" name="Shape 71"/>
           <p:cNvSpPr/>
           <p:nvPr/>
         </p:nvSpPr>
@@ -17788,7 +17944,7 @@
       </p:sp>
       <p:sp>
         <p:nvSpPr>
-          <p:cNvPr id="74" name="Text 72"/>
+          <p:cNvPr id="76" name="Text 72"/>
           <p:cNvSpPr/>
           <p:nvPr/>
         </p:nvSpPr>
@@ -17830,7 +17986,7 @@
       </p:sp>
       <p:sp>
         <p:nvSpPr>
-          <p:cNvPr id="75" name="Shape 73"/>
+          <p:cNvPr id="77" name="Shape 73"/>
           <p:cNvSpPr/>
           <p:nvPr/>
         </p:nvSpPr>
@@ -17860,16 +18016,40 @@
           </a:effectLst>
         </p:spPr>
       </p:sp>
-      <p:sp>
-        <p:nvSpPr>
-          <p:cNvPr id="76" name="Text 74"/>
-          <p:cNvSpPr/>
-          <p:nvPr/>
-        </p:nvSpPr>
-        <p:spPr>
-          <a:xfrm>
-            <a:off x="6108192" y="3493008"/>
-            <a:ext cx="2560320" cy="274320"/>
+      <p:pic>
+        <p:nvPicPr>
+          <p:cNvPr id="78" name="Image 2" descr="preencoded.png">    </p:cNvPr>
+          <p:cNvPicPr>
+            <a:picLocks noChangeAspect="1"/>
+          </p:cNvPicPr>
+          <p:nvPr/>
+        </p:nvPicPr>
+        <p:blipFill>
+          <a:blip r:embed="rId3"/>
+          <a:stretch>
+            <a:fillRect/>
+          </a:stretch>
+        </p:blipFill>
+        <p:spPr>
+          <a:xfrm>
+            <a:off x="6035040" y="3493008"/>
+            <a:ext cx="274320" cy="274320"/>
+          </a:xfrm>
+          <a:prstGeom prst="rect">
+            <a:avLst/>
+          </a:prstGeom>
+        </p:spPr>
+      </p:pic>
+      <p:sp>
+        <p:nvSpPr>
+          <p:cNvPr id="79" name="Text 74"/>
+          <p:cNvSpPr/>
+          <p:nvPr/>
+        </p:nvSpPr>
+        <p:spPr>
+          <a:xfrm>
+            <a:off x="6364224" y="3493008"/>
+            <a:ext cx="2304288" cy="274320"/>
           </a:xfrm>
           <a:prstGeom prst="rect">
             <a:avLst/>
@@ -17893,7 +18073,7 @@
                 <a:ea typeface="Courier New" pitchFamily="34" charset="-122"/>
                 <a:cs typeface="Courier New" pitchFamily="34" charset="-120"/>
               </a:rPr>
-              <a:t>📈  INVESTMENT</a:t>
+              <a:t>INVESTMENT</a:t>
             </a:r>
             <a:endParaRPr lang="en-US" sz="950" dirty="0"/>
           </a:p>
@@ -17901,7 +18081,7 @@
       </p:sp>
       <p:sp>
         <p:nvSpPr>
-          <p:cNvPr id="77" name="Text 75"/>
+          <p:cNvPr id="80" name="Text 75"/>
           <p:cNvSpPr/>
           <p:nvPr/>
         </p:nvSpPr>
@@ -17940,7 +18120,7 @@
       </p:sp>
       <p:sp>
         <p:nvSpPr>
-          <p:cNvPr id="78" name="Shape 76"/>
+          <p:cNvPr id="81" name="Shape 76"/>
           <p:cNvSpPr/>
           <p:nvPr/>
         </p:nvSpPr>
@@ -17963,7 +18143,7 @@
       </p:sp>
       <p:sp>
         <p:nvSpPr>
-          <p:cNvPr id="79" name="Text 77"/>
+          <p:cNvPr id="82" name="Text 77"/>
           <p:cNvSpPr/>
           <p:nvPr/>
         </p:nvSpPr>

</xml_diff>